<commit_message>
WMC answer1 answers added for cs2
</commit_message>
<xml_diff>
--- a/MT/CS1_MWT Intro.pptx
+++ b/MT/CS1_MWT Intro.pptx
@@ -32,9 +32,6 @@
     <p:sldId id="283" r:id="rId26"/>
     <p:sldId id="284" r:id="rId27"/>
     <p:sldId id="285" r:id="rId28"/>
-    <p:sldId id="286" r:id="rId29"/>
-    <p:sldId id="287" r:id="rId30"/>
-    <p:sldId id="288" r:id="rId31"/>
   </p:sldIdLst>
   <p:sldSz cx="10058400" cy="7772400"/>
   <p:notesSz cx="10058400" cy="7772400"/>
@@ -254,7 +251,7 @@
           <a:p>
             <a:fld id="{1D8BD707-D9CF-40AE-B4C6-C98DA3205C09}" type="datetimeFigureOut">
               <a:rPr lang="en-US"/>
-              <a:t>4/6/2025</a:t>
+              <a:t>4/11/2025</a:t>
             </a:fld>
             <a:endParaRPr lang="en-US"/>
           </a:p>
@@ -472,7 +469,7 @@
           <a:p>
             <a:fld id="{1D8BD707-D9CF-40AE-B4C6-C98DA3205C09}" type="datetimeFigureOut">
               <a:rPr lang="en-US"/>
-              <a:t>4/6/2025</a:t>
+              <a:t>4/11/2025</a:t>
             </a:fld>
             <a:endParaRPr lang="en-US"/>
           </a:p>
@@ -739,7 +736,7 @@
           <a:p>
             <a:fld id="{1D8BD707-D9CF-40AE-B4C6-C98DA3205C09}" type="datetimeFigureOut">
               <a:rPr lang="en-US"/>
-              <a:t>4/6/2025</a:t>
+              <a:t>4/11/2025</a:t>
             </a:fld>
             <a:endParaRPr lang="en-US"/>
           </a:p>
@@ -928,7 +925,7 @@
           <a:p>
             <a:fld id="{1D8BD707-D9CF-40AE-B4C6-C98DA3205C09}" type="datetimeFigureOut">
               <a:rPr lang="en-US"/>
-              <a:t>4/6/2025</a:t>
+              <a:t>4/11/2025</a:t>
             </a:fld>
             <a:endParaRPr lang="en-US"/>
           </a:p>
@@ -1396,7 +1393,7 @@
           <a:p>
             <a:fld id="{1D8BD707-D9CF-40AE-B4C6-C98DA3205C09}" type="datetimeFigureOut">
               <a:rPr lang="en-US"/>
-              <a:t>4/6/2025</a:t>
+              <a:t>4/11/2025</a:t>
             </a:fld>
             <a:endParaRPr lang="en-US"/>
           </a:p>
@@ -2134,7 +2131,7 @@
           <a:p>
             <a:fld id="{1D8BD707-D9CF-40AE-B4C6-C98DA3205C09}" type="datetimeFigureOut">
               <a:rPr lang="en-US"/>
-              <a:t>4/6/2025</a:t>
+              <a:t>4/11/2025</a:t>
             </a:fld>
             <a:endParaRPr lang="en-US"/>
           </a:p>
@@ -32345,908 +32342,6 @@
 </p:sld>
 </file>
 
-<file path=ppt/slides/slide28.xml><?xml version="1.0" encoding="utf-8"?>
-<p:sld xmlns:a="http://schemas.openxmlformats.org/drawingml/2006/main" xmlns:r="http://schemas.openxmlformats.org/officeDocument/2006/relationships" xmlns:p="http://schemas.openxmlformats.org/presentationml/2006/main">
-  <p:cSld>
-    <p:spTree>
-      <p:nvGrpSpPr>
-        <p:cNvPr id="1" name=""/>
-        <p:cNvGrpSpPr/>
-        <p:nvPr/>
-      </p:nvGrpSpPr>
-      <p:grpSpPr>
-        <a:xfrm>
-          <a:off x="0" y="0"/>
-          <a:ext cx="0" cy="0"/>
-          <a:chOff x="0" y="0"/>
-          <a:chExt cx="0" cy="0"/>
-        </a:xfrm>
-      </p:grpSpPr>
-      <p:sp>
-        <p:nvSpPr>
-          <p:cNvPr id="2" name="object 2"/>
-          <p:cNvSpPr txBox="1">
-            <a:spLocks noGrp="1"/>
-          </p:cNvSpPr>
-          <p:nvPr>
-            <p:ph type="title"/>
-          </p:nvPr>
-        </p:nvSpPr>
-        <p:spPr>
-          <a:prstGeom prst="rect">
-            <a:avLst/>
-          </a:prstGeom>
-        </p:spPr>
-        <p:txBody>
-          <a:bodyPr vert="horz" wrap="square" lIns="0" tIns="238362" rIns="0" bIns="0" rtlCol="0">
-            <a:spAutoFit/>
-          </a:bodyPr>
-          <a:lstStyle/>
-          <a:p>
-            <a:pPr marL="88900">
-              <a:lnSpc>
-                <a:spcPct val="100000"/>
-              </a:lnSpc>
-              <a:spcBef>
-                <a:spcPts val="125"/>
-              </a:spcBef>
-            </a:pPr>
-            <a:r>
-              <a:rPr spc="130" dirty="0"/>
-              <a:t>Summary</a:t>
-            </a:r>
-          </a:p>
-        </p:txBody>
-      </p:sp>
-      <p:sp>
-        <p:nvSpPr>
-          <p:cNvPr id="4" name="object 4"/>
-          <p:cNvSpPr txBox="1">
-            <a:spLocks noGrp="1"/>
-          </p:cNvSpPr>
-          <p:nvPr>
-            <p:ph type="ftr" sz="quarter" idx="5"/>
-          </p:nvPr>
-        </p:nvSpPr>
-        <p:spPr>
-          <a:prstGeom prst="rect">
-            <a:avLst/>
-          </a:prstGeom>
-        </p:spPr>
-        <p:txBody>
-          <a:bodyPr vert="horz" wrap="square" lIns="0" tIns="3175" rIns="0" bIns="0" rtlCol="0">
-            <a:spAutoFit/>
-          </a:bodyPr>
-          <a:lstStyle/>
-          <a:p>
-            <a:pPr marL="12700">
-              <a:lnSpc>
-                <a:spcPct val="100000"/>
-              </a:lnSpc>
-              <a:spcBef>
-                <a:spcPts val="25"/>
-              </a:spcBef>
-            </a:pPr>
-            <a:r>
-              <a:rPr b="1" dirty="0">
-                <a:latin typeface="Arial"/>
-                <a:cs typeface="Arial"/>
-              </a:rPr>
-              <a:t>BITS</a:t>
-            </a:r>
-            <a:r>
-              <a:rPr b="1" spc="-10" dirty="0">
-                <a:latin typeface="Arial"/>
-                <a:cs typeface="Arial"/>
-              </a:rPr>
-              <a:t> </a:t>
-            </a:r>
-            <a:r>
-              <a:rPr dirty="0"/>
-              <a:t>Pilani,</a:t>
-            </a:r>
-            <a:r>
-              <a:rPr spc="5" dirty="0"/>
-              <a:t> </a:t>
-            </a:r>
-            <a:r>
-              <a:rPr dirty="0"/>
-              <a:t>Pilani</a:t>
-            </a:r>
-            <a:r>
-              <a:rPr spc="10" dirty="0"/>
-              <a:t> </a:t>
-            </a:r>
-            <a:r>
-              <a:rPr spc="-10" dirty="0"/>
-              <a:t>Campus</a:t>
-            </a:r>
-          </a:p>
-        </p:txBody>
-      </p:sp>
-      <p:sp>
-        <p:nvSpPr>
-          <p:cNvPr id="3" name="object 3"/>
-          <p:cNvSpPr txBox="1"/>
-          <p:nvPr/>
-        </p:nvSpPr>
-        <p:spPr>
-          <a:xfrm>
-            <a:off x="304309" y="2382994"/>
-            <a:ext cx="7769225" cy="3620135"/>
-          </a:xfrm>
-          <a:prstGeom prst="rect">
-            <a:avLst/>
-          </a:prstGeom>
-        </p:spPr>
-        <p:txBody>
-          <a:bodyPr vert="horz" wrap="square" lIns="0" tIns="13335" rIns="0" bIns="0" rtlCol="0">
-            <a:spAutoFit/>
-          </a:bodyPr>
-          <a:lstStyle/>
-          <a:p>
-            <a:pPr marL="295910" indent="-283210">
-              <a:lnSpc>
-                <a:spcPct val="100000"/>
-              </a:lnSpc>
-              <a:spcBef>
-                <a:spcPts val="105"/>
-              </a:spcBef>
-              <a:buFont typeface="Wingdings"/>
-              <a:buChar char=""/>
-              <a:tabLst>
-                <a:tab pos="295910" algn="l"/>
-                <a:tab pos="5732145" algn="l"/>
-              </a:tabLst>
-            </a:pPr>
-            <a:r>
-              <a:rPr sz="1650" spc="75" dirty="0">
-                <a:latin typeface="Cambria"/>
-                <a:cs typeface="Cambria"/>
-              </a:rPr>
-              <a:t>Middleware</a:t>
-            </a:r>
-            <a:r>
-              <a:rPr sz="1650" spc="135" dirty="0">
-                <a:latin typeface="Cambria"/>
-                <a:cs typeface="Cambria"/>
-              </a:rPr>
-              <a:t> </a:t>
-            </a:r>
-            <a:r>
-              <a:rPr sz="1650" spc="85" dirty="0">
-                <a:latin typeface="Cambria"/>
-                <a:cs typeface="Cambria"/>
-              </a:rPr>
-              <a:t>is</a:t>
-            </a:r>
-            <a:r>
-              <a:rPr sz="1650" spc="180" dirty="0">
-                <a:latin typeface="Cambria"/>
-                <a:cs typeface="Cambria"/>
-              </a:rPr>
-              <a:t> </a:t>
-            </a:r>
-            <a:r>
-              <a:rPr sz="1650" spc="160" dirty="0">
-                <a:latin typeface="Cambria"/>
-                <a:cs typeface="Cambria"/>
-              </a:rPr>
-              <a:t>an</a:t>
-            </a:r>
-            <a:r>
-              <a:rPr sz="1650" spc="190" dirty="0">
-                <a:latin typeface="Cambria"/>
-                <a:cs typeface="Cambria"/>
-              </a:rPr>
-              <a:t> </a:t>
-            </a:r>
-            <a:r>
-              <a:rPr sz="1650" spc="90" dirty="0">
-                <a:latin typeface="Cambria"/>
-                <a:cs typeface="Cambria"/>
-              </a:rPr>
-              <a:t>important</a:t>
-            </a:r>
-            <a:r>
-              <a:rPr sz="1650" spc="175" dirty="0">
-                <a:latin typeface="Cambria"/>
-                <a:cs typeface="Cambria"/>
-              </a:rPr>
-              <a:t> </a:t>
-            </a:r>
-            <a:r>
-              <a:rPr sz="1650" spc="95" dirty="0">
-                <a:latin typeface="Cambria"/>
-                <a:cs typeface="Cambria"/>
-              </a:rPr>
-              <a:t>abstraction</a:t>
-            </a:r>
-            <a:r>
-              <a:rPr sz="1650" spc="170" dirty="0">
-                <a:latin typeface="Cambria"/>
-                <a:cs typeface="Cambria"/>
-              </a:rPr>
-              <a:t> </a:t>
-            </a:r>
-            <a:r>
-              <a:rPr sz="1650" dirty="0">
-                <a:latin typeface="Cambria"/>
-                <a:cs typeface="Cambria"/>
-              </a:rPr>
-              <a:t>for</a:t>
-            </a:r>
-            <a:r>
-              <a:rPr sz="1650" spc="195" dirty="0">
-                <a:latin typeface="Cambria"/>
-                <a:cs typeface="Cambria"/>
-              </a:rPr>
-              <a:t> </a:t>
-            </a:r>
-            <a:r>
-              <a:rPr sz="1650" spc="85" dirty="0">
-                <a:latin typeface="Cambria"/>
-                <a:cs typeface="Cambria"/>
-              </a:rPr>
-              <a:t>building</a:t>
-            </a:r>
-            <a:r>
-              <a:rPr sz="1650" dirty="0">
-                <a:latin typeface="Cambria"/>
-                <a:cs typeface="Cambria"/>
-              </a:rPr>
-              <a:t>	</a:t>
-            </a:r>
-            <a:r>
-              <a:rPr sz="1650" spc="85" dirty="0">
-                <a:latin typeface="Cambria"/>
-                <a:cs typeface="Cambria"/>
-              </a:rPr>
-              <a:t>distributed</a:t>
-            </a:r>
-            <a:r>
-              <a:rPr sz="1650" spc="150" dirty="0">
-                <a:latin typeface="Cambria"/>
-                <a:cs typeface="Cambria"/>
-              </a:rPr>
-              <a:t> </a:t>
-            </a:r>
-            <a:r>
-              <a:rPr sz="1650" spc="95" dirty="0">
-                <a:latin typeface="Cambria"/>
-                <a:cs typeface="Cambria"/>
-              </a:rPr>
-              <a:t>systems</a:t>
-            </a:r>
-            <a:endParaRPr sz="1650">
-              <a:latin typeface="Cambria"/>
-              <a:cs typeface="Cambria"/>
-            </a:endParaRPr>
-          </a:p>
-          <a:p>
-            <a:pPr marL="829310" lvl="1" indent="-376555">
-              <a:lnSpc>
-                <a:spcPct val="100000"/>
-              </a:lnSpc>
-              <a:spcBef>
-                <a:spcPts val="1320"/>
-              </a:spcBef>
-              <a:buAutoNum type="arabicPeriod"/>
-              <a:tabLst>
-                <a:tab pos="829310" algn="l"/>
-              </a:tabLst>
-            </a:pPr>
-            <a:r>
-              <a:rPr sz="1650" spc="85" dirty="0">
-                <a:latin typeface="Cambria"/>
-                <a:cs typeface="Cambria"/>
-              </a:rPr>
-              <a:t>Remote</a:t>
-            </a:r>
-            <a:r>
-              <a:rPr sz="1650" spc="140" dirty="0">
-                <a:latin typeface="Cambria"/>
-                <a:cs typeface="Cambria"/>
-              </a:rPr>
-              <a:t> </a:t>
-            </a:r>
-            <a:r>
-              <a:rPr sz="1650" spc="75" dirty="0">
-                <a:latin typeface="Cambria"/>
-                <a:cs typeface="Cambria"/>
-              </a:rPr>
-              <a:t>Procedure</a:t>
-            </a:r>
-            <a:r>
-              <a:rPr sz="1650" spc="125" dirty="0">
-                <a:latin typeface="Cambria"/>
-                <a:cs typeface="Cambria"/>
-              </a:rPr>
-              <a:t> </a:t>
-            </a:r>
-            <a:r>
-              <a:rPr sz="1650" spc="110" dirty="0">
-                <a:latin typeface="Cambria"/>
-                <a:cs typeface="Cambria"/>
-              </a:rPr>
-              <a:t>Call</a:t>
-            </a:r>
-            <a:endParaRPr sz="1650">
-              <a:latin typeface="Cambria"/>
-              <a:cs typeface="Cambria"/>
-            </a:endParaRPr>
-          </a:p>
-          <a:p>
-            <a:pPr marL="829310" lvl="1" indent="-376555">
-              <a:lnSpc>
-                <a:spcPct val="100000"/>
-              </a:lnSpc>
-              <a:spcBef>
-                <a:spcPts val="1475"/>
-              </a:spcBef>
-              <a:buAutoNum type="arabicPeriod"/>
-              <a:tabLst>
-                <a:tab pos="829310" algn="l"/>
-              </a:tabLst>
-            </a:pPr>
-            <a:r>
-              <a:rPr sz="1650" spc="105" dirty="0">
-                <a:latin typeface="Cambria"/>
-                <a:cs typeface="Cambria"/>
-              </a:rPr>
-              <a:t>Object-</a:t>
-            </a:r>
-            <a:r>
-              <a:rPr sz="1650" spc="85" dirty="0">
-                <a:latin typeface="Cambria"/>
-                <a:cs typeface="Cambria"/>
-              </a:rPr>
-              <a:t>Oriented</a:t>
-            </a:r>
-            <a:r>
-              <a:rPr sz="1650" spc="170" dirty="0">
-                <a:latin typeface="Cambria"/>
-                <a:cs typeface="Cambria"/>
-              </a:rPr>
-              <a:t> </a:t>
-            </a:r>
-            <a:r>
-              <a:rPr sz="1650" spc="60" dirty="0">
-                <a:latin typeface="Cambria"/>
-                <a:cs typeface="Cambria"/>
-              </a:rPr>
-              <a:t>Middleware</a:t>
-            </a:r>
-            <a:endParaRPr sz="1650">
-              <a:latin typeface="Cambria"/>
-              <a:cs typeface="Cambria"/>
-            </a:endParaRPr>
-          </a:p>
-          <a:p>
-            <a:pPr marL="829310" lvl="1" indent="-376555">
-              <a:lnSpc>
-                <a:spcPct val="100000"/>
-              </a:lnSpc>
-              <a:spcBef>
-                <a:spcPts val="1490"/>
-              </a:spcBef>
-              <a:buAutoNum type="arabicPeriod"/>
-              <a:tabLst>
-                <a:tab pos="829310" algn="l"/>
-              </a:tabLst>
-            </a:pPr>
-            <a:r>
-              <a:rPr sz="1650" spc="105" dirty="0">
-                <a:latin typeface="Cambria"/>
-                <a:cs typeface="Cambria"/>
-              </a:rPr>
-              <a:t>Message-</a:t>
-            </a:r>
-            <a:r>
-              <a:rPr sz="1650" spc="85" dirty="0">
-                <a:latin typeface="Cambria"/>
-                <a:cs typeface="Cambria"/>
-              </a:rPr>
-              <a:t>Oriented</a:t>
-            </a:r>
-            <a:r>
-              <a:rPr sz="1650" spc="160" dirty="0">
-                <a:latin typeface="Cambria"/>
-                <a:cs typeface="Cambria"/>
-              </a:rPr>
-              <a:t> </a:t>
-            </a:r>
-            <a:r>
-              <a:rPr sz="1650" spc="60" dirty="0">
-                <a:latin typeface="Cambria"/>
-                <a:cs typeface="Cambria"/>
-              </a:rPr>
-              <a:t>Middleware</a:t>
-            </a:r>
-            <a:endParaRPr sz="1650">
-              <a:latin typeface="Cambria"/>
-              <a:cs typeface="Cambria"/>
-            </a:endParaRPr>
-          </a:p>
-          <a:p>
-            <a:pPr marL="829310" lvl="1" indent="-376555">
-              <a:lnSpc>
-                <a:spcPct val="100000"/>
-              </a:lnSpc>
-              <a:spcBef>
-                <a:spcPts val="1485"/>
-              </a:spcBef>
-              <a:buAutoNum type="arabicPeriod"/>
-              <a:tabLst>
-                <a:tab pos="829310" algn="l"/>
-              </a:tabLst>
-            </a:pPr>
-            <a:r>
-              <a:rPr sz="1650" spc="105" dirty="0">
-                <a:latin typeface="Cambria"/>
-                <a:cs typeface="Cambria"/>
-              </a:rPr>
-              <a:t>Event-</a:t>
-            </a:r>
-            <a:r>
-              <a:rPr sz="1650" spc="125" dirty="0">
-                <a:latin typeface="Cambria"/>
-                <a:cs typeface="Cambria"/>
-              </a:rPr>
-              <a:t>Based</a:t>
-            </a:r>
-            <a:r>
-              <a:rPr sz="1650" spc="105" dirty="0">
-                <a:latin typeface="Cambria"/>
-                <a:cs typeface="Cambria"/>
-              </a:rPr>
-              <a:t> </a:t>
-            </a:r>
-            <a:r>
-              <a:rPr sz="1650" spc="60" dirty="0">
-                <a:latin typeface="Cambria"/>
-                <a:cs typeface="Cambria"/>
-              </a:rPr>
-              <a:t>Middleware</a:t>
-            </a:r>
-            <a:endParaRPr sz="1650">
-              <a:latin typeface="Cambria"/>
-              <a:cs typeface="Cambria"/>
-            </a:endParaRPr>
-          </a:p>
-          <a:p>
-            <a:pPr marL="295910" indent="-283210">
-              <a:lnSpc>
-                <a:spcPct val="100000"/>
-              </a:lnSpc>
-              <a:spcBef>
-                <a:spcPts val="1070"/>
-              </a:spcBef>
-              <a:buFont typeface="Wingdings"/>
-              <a:buChar char=""/>
-              <a:tabLst>
-                <a:tab pos="295910" algn="l"/>
-              </a:tabLst>
-            </a:pPr>
-            <a:r>
-              <a:rPr sz="1650" spc="125" dirty="0">
-                <a:latin typeface="Cambria"/>
-                <a:cs typeface="Cambria"/>
-              </a:rPr>
-              <a:t>Synchronous</a:t>
-            </a:r>
-            <a:r>
-              <a:rPr sz="1650" spc="145" dirty="0">
-                <a:latin typeface="Cambria"/>
-                <a:cs typeface="Cambria"/>
-              </a:rPr>
-              <a:t> </a:t>
-            </a:r>
-            <a:r>
-              <a:rPr sz="1650" spc="114" dirty="0">
-                <a:latin typeface="Cambria"/>
-                <a:cs typeface="Cambria"/>
-              </a:rPr>
-              <a:t>vs.</a:t>
-            </a:r>
-            <a:r>
-              <a:rPr sz="1650" spc="180" dirty="0">
-                <a:latin typeface="Cambria"/>
-                <a:cs typeface="Cambria"/>
-              </a:rPr>
-              <a:t> </a:t>
-            </a:r>
-            <a:r>
-              <a:rPr sz="1650" spc="114" dirty="0">
-                <a:latin typeface="Cambria"/>
-                <a:cs typeface="Cambria"/>
-              </a:rPr>
-              <a:t>asynchronous</a:t>
-            </a:r>
-            <a:r>
-              <a:rPr sz="1650" spc="145" dirty="0">
-                <a:latin typeface="Cambria"/>
-                <a:cs typeface="Cambria"/>
-              </a:rPr>
-              <a:t> </a:t>
-            </a:r>
-            <a:r>
-              <a:rPr sz="1650" spc="105" dirty="0">
-                <a:latin typeface="Cambria"/>
-                <a:cs typeface="Cambria"/>
-              </a:rPr>
-              <a:t>communication</a:t>
-            </a:r>
-            <a:endParaRPr sz="1650">
-              <a:latin typeface="Cambria"/>
-              <a:cs typeface="Cambria"/>
-            </a:endParaRPr>
-          </a:p>
-          <a:p>
-            <a:pPr marL="295910" indent="-283210">
-              <a:lnSpc>
-                <a:spcPct val="100000"/>
-              </a:lnSpc>
-              <a:spcBef>
-                <a:spcPts val="1080"/>
-              </a:spcBef>
-              <a:buFont typeface="Wingdings"/>
-              <a:buChar char=""/>
-              <a:tabLst>
-                <a:tab pos="295910" algn="l"/>
-              </a:tabLst>
-            </a:pPr>
-            <a:r>
-              <a:rPr sz="1650" spc="105" dirty="0">
-                <a:latin typeface="Cambria"/>
-                <a:cs typeface="Cambria"/>
-              </a:rPr>
-              <a:t>Scalability,</a:t>
-            </a:r>
-            <a:r>
-              <a:rPr sz="1650" spc="155" dirty="0">
-                <a:latin typeface="Cambria"/>
-                <a:cs typeface="Cambria"/>
-              </a:rPr>
-              <a:t> </a:t>
-            </a:r>
-            <a:r>
-              <a:rPr sz="1650" spc="130" dirty="0">
-                <a:latin typeface="Cambria"/>
-                <a:cs typeface="Cambria"/>
-              </a:rPr>
-              <a:t>many-</a:t>
-            </a:r>
-            <a:r>
-              <a:rPr sz="1650" spc="65" dirty="0">
-                <a:latin typeface="Cambria"/>
-                <a:cs typeface="Cambria"/>
-              </a:rPr>
-              <a:t>to-</a:t>
-            </a:r>
-            <a:r>
-              <a:rPr sz="1650" spc="135" dirty="0">
-                <a:latin typeface="Cambria"/>
-                <a:cs typeface="Cambria"/>
-              </a:rPr>
-              <a:t>many </a:t>
-            </a:r>
-            <a:r>
-              <a:rPr sz="1650" spc="100" dirty="0">
-                <a:latin typeface="Cambria"/>
-                <a:cs typeface="Cambria"/>
-              </a:rPr>
-              <a:t>communication</a:t>
-            </a:r>
-            <a:endParaRPr sz="1650">
-              <a:latin typeface="Cambria"/>
-              <a:cs typeface="Cambria"/>
-            </a:endParaRPr>
-          </a:p>
-          <a:p>
-            <a:pPr marL="295910" indent="-283210">
-              <a:lnSpc>
-                <a:spcPct val="100000"/>
-              </a:lnSpc>
-              <a:spcBef>
-                <a:spcPts val="1070"/>
-              </a:spcBef>
-              <a:buFont typeface="Wingdings"/>
-              <a:buChar char=""/>
-              <a:tabLst>
-                <a:tab pos="295910" algn="l"/>
-              </a:tabLst>
-            </a:pPr>
-            <a:r>
-              <a:rPr sz="1650" spc="120" dirty="0">
-                <a:latin typeface="Cambria"/>
-                <a:cs typeface="Cambria"/>
-              </a:rPr>
-              <a:t>Language</a:t>
-            </a:r>
-            <a:r>
-              <a:rPr sz="1650" spc="150" dirty="0">
-                <a:latin typeface="Cambria"/>
-                <a:cs typeface="Cambria"/>
-              </a:rPr>
-              <a:t> </a:t>
-            </a:r>
-            <a:r>
-              <a:rPr sz="1650" spc="65" dirty="0">
-                <a:latin typeface="Cambria"/>
-                <a:cs typeface="Cambria"/>
-              </a:rPr>
-              <a:t>integration</a:t>
-            </a:r>
-            <a:endParaRPr sz="1650">
-              <a:latin typeface="Cambria"/>
-              <a:cs typeface="Cambria"/>
-            </a:endParaRPr>
-          </a:p>
-          <a:p>
-            <a:pPr marL="295910" indent="-283210">
-              <a:lnSpc>
-                <a:spcPct val="100000"/>
-              </a:lnSpc>
-              <a:spcBef>
-                <a:spcPts val="1485"/>
-              </a:spcBef>
-              <a:buFont typeface="Wingdings"/>
-              <a:buChar char=""/>
-              <a:tabLst>
-                <a:tab pos="295910" algn="l"/>
-              </a:tabLst>
-            </a:pPr>
-            <a:r>
-              <a:rPr sz="1650" spc="110" dirty="0">
-                <a:latin typeface="Cambria"/>
-                <a:cs typeface="Cambria"/>
-              </a:rPr>
-              <a:t>Ubiquitous</a:t>
-            </a:r>
-            <a:r>
-              <a:rPr sz="1650" spc="140" dirty="0">
-                <a:latin typeface="Cambria"/>
-                <a:cs typeface="Cambria"/>
-              </a:rPr>
-              <a:t> </a:t>
-            </a:r>
-            <a:r>
-              <a:rPr sz="1650" spc="120" dirty="0">
-                <a:latin typeface="Cambria"/>
-                <a:cs typeface="Cambria"/>
-              </a:rPr>
-              <a:t>systems,</a:t>
-            </a:r>
-            <a:r>
-              <a:rPr sz="1650" spc="110" dirty="0">
-                <a:latin typeface="Cambria"/>
-                <a:cs typeface="Cambria"/>
-              </a:rPr>
-              <a:t> </a:t>
-            </a:r>
-            <a:r>
-              <a:rPr sz="1650" spc="75" dirty="0">
-                <a:latin typeface="Cambria"/>
-                <a:cs typeface="Cambria"/>
-              </a:rPr>
-              <a:t>mobile</a:t>
-            </a:r>
-            <a:r>
-              <a:rPr sz="1650" spc="165" dirty="0">
-                <a:latin typeface="Cambria"/>
-                <a:cs typeface="Cambria"/>
-              </a:rPr>
-              <a:t> </a:t>
-            </a:r>
-            <a:r>
-              <a:rPr sz="1650" spc="95" dirty="0">
-                <a:latin typeface="Cambria"/>
-                <a:cs typeface="Cambria"/>
-              </a:rPr>
-              <a:t>systems</a:t>
-            </a:r>
-            <a:endParaRPr sz="1650">
-              <a:latin typeface="Cambria"/>
-              <a:cs typeface="Cambria"/>
-            </a:endParaRPr>
-          </a:p>
-        </p:txBody>
-      </p:sp>
-    </p:spTree>
-  </p:cSld>
-  <p:clrMapOvr>
-    <a:masterClrMapping/>
-  </p:clrMapOvr>
-</p:sld>
-</file>
-
-<file path=ppt/slides/slide29.xml><?xml version="1.0" encoding="utf-8"?>
-<p:sld xmlns:a="http://schemas.openxmlformats.org/drawingml/2006/main" xmlns:r="http://schemas.openxmlformats.org/officeDocument/2006/relationships" xmlns:p="http://schemas.openxmlformats.org/presentationml/2006/main">
-  <p:cSld>
-    <p:spTree>
-      <p:nvGrpSpPr>
-        <p:cNvPr id="1" name=""/>
-        <p:cNvGrpSpPr/>
-        <p:nvPr/>
-      </p:nvGrpSpPr>
-      <p:grpSpPr>
-        <a:xfrm>
-          <a:off x="0" y="0"/>
-          <a:ext cx="0" cy="0"/>
-          <a:chOff x="0" y="0"/>
-          <a:chExt cx="0" cy="0"/>
-        </a:xfrm>
-      </p:grpSpPr>
-      <p:sp>
-        <p:nvSpPr>
-          <p:cNvPr id="2" name="object 2"/>
-          <p:cNvSpPr txBox="1"/>
-          <p:nvPr/>
-        </p:nvSpPr>
-        <p:spPr>
-          <a:xfrm>
-            <a:off x="8361708" y="6314975"/>
-            <a:ext cx="217804" cy="252729"/>
-          </a:xfrm>
-          <a:prstGeom prst="rect">
-            <a:avLst/>
-          </a:prstGeom>
-        </p:spPr>
-        <p:txBody>
-          <a:bodyPr vert="horz" wrap="square" lIns="0" tIns="17145" rIns="0" bIns="0" rtlCol="0">
-            <a:spAutoFit/>
-          </a:bodyPr>
-          <a:lstStyle/>
-          <a:p>
-            <a:pPr marL="12700">
-              <a:lnSpc>
-                <a:spcPct val="100000"/>
-              </a:lnSpc>
-              <a:spcBef>
-                <a:spcPts val="135"/>
-              </a:spcBef>
-            </a:pPr>
-            <a:r>
-              <a:rPr sz="1450" spc="-25" dirty="0">
-                <a:latin typeface="Calibri"/>
-                <a:cs typeface="Calibri"/>
-              </a:rPr>
-              <a:t>32</a:t>
-            </a:r>
-            <a:endParaRPr sz="1450">
-              <a:latin typeface="Calibri"/>
-              <a:cs typeface="Calibri"/>
-            </a:endParaRPr>
-          </a:p>
-        </p:txBody>
-      </p:sp>
-      <p:sp>
-        <p:nvSpPr>
-          <p:cNvPr id="4" name="object 4"/>
-          <p:cNvSpPr txBox="1">
-            <a:spLocks noGrp="1"/>
-          </p:cNvSpPr>
-          <p:nvPr>
-            <p:ph type="ftr" sz="quarter" idx="5"/>
-          </p:nvPr>
-        </p:nvSpPr>
-        <p:spPr>
-          <a:prstGeom prst="rect">
-            <a:avLst/>
-          </a:prstGeom>
-        </p:spPr>
-        <p:txBody>
-          <a:bodyPr vert="horz" wrap="square" lIns="0" tIns="3175" rIns="0" bIns="0" rtlCol="0">
-            <a:spAutoFit/>
-          </a:bodyPr>
-          <a:lstStyle/>
-          <a:p>
-            <a:pPr marL="12700">
-              <a:lnSpc>
-                <a:spcPct val="100000"/>
-              </a:lnSpc>
-              <a:spcBef>
-                <a:spcPts val="25"/>
-              </a:spcBef>
-            </a:pPr>
-            <a:r>
-              <a:rPr b="1" dirty="0">
-                <a:latin typeface="Arial"/>
-                <a:cs typeface="Arial"/>
-              </a:rPr>
-              <a:t>BITS</a:t>
-            </a:r>
-            <a:r>
-              <a:rPr b="1" spc="-10" dirty="0">
-                <a:latin typeface="Arial"/>
-                <a:cs typeface="Arial"/>
-              </a:rPr>
-              <a:t> </a:t>
-            </a:r>
-            <a:r>
-              <a:rPr dirty="0"/>
-              <a:t>Pilani,</a:t>
-            </a:r>
-            <a:r>
-              <a:rPr spc="5" dirty="0"/>
-              <a:t> </a:t>
-            </a:r>
-            <a:r>
-              <a:rPr dirty="0"/>
-              <a:t>Pilani</a:t>
-            </a:r>
-            <a:r>
-              <a:rPr spc="10" dirty="0"/>
-              <a:t> </a:t>
-            </a:r>
-            <a:r>
-              <a:rPr spc="-10" dirty="0"/>
-              <a:t>Campus</a:t>
-            </a:r>
-          </a:p>
-        </p:txBody>
-      </p:sp>
-      <p:sp>
-        <p:nvSpPr>
-          <p:cNvPr id="3" name="object 3"/>
-          <p:cNvSpPr txBox="1">
-            <a:spLocks noGrp="1"/>
-          </p:cNvSpPr>
-          <p:nvPr>
-            <p:ph type="title"/>
-          </p:nvPr>
-        </p:nvSpPr>
-        <p:spPr>
-          <a:xfrm>
-            <a:off x="2454872" y="3398051"/>
-            <a:ext cx="5207635" cy="1132205"/>
-          </a:xfrm>
-          <a:prstGeom prst="rect">
-            <a:avLst/>
-          </a:prstGeom>
-        </p:spPr>
-        <p:txBody>
-          <a:bodyPr vert="horz" wrap="square" lIns="0" tIns="13970" rIns="0" bIns="0" rtlCol="0">
-            <a:spAutoFit/>
-          </a:bodyPr>
-          <a:lstStyle/>
-          <a:p>
-            <a:pPr marL="12700">
-              <a:lnSpc>
-                <a:spcPct val="100000"/>
-              </a:lnSpc>
-              <a:spcBef>
-                <a:spcPts val="110"/>
-              </a:spcBef>
-              <a:tabLst>
-                <a:tab pos="3368675" algn="l"/>
-              </a:tabLst>
-            </a:pPr>
-            <a:r>
-              <a:rPr sz="7250" spc="450" dirty="0"/>
-              <a:t>Thank</a:t>
-            </a:r>
-            <a:r>
-              <a:rPr sz="7250" dirty="0"/>
-              <a:t>	</a:t>
-            </a:r>
-            <a:r>
-              <a:rPr sz="7250" spc="455" dirty="0"/>
-              <a:t>You</a:t>
-            </a:r>
-            <a:endParaRPr sz="7250"/>
-          </a:p>
-        </p:txBody>
-      </p:sp>
-    </p:spTree>
-  </p:cSld>
-  <p:clrMapOvr>
-    <a:masterClrMapping/>
-  </p:clrMapOvr>
-</p:sld>
-</file>
-
 <file path=ppt/slides/slide3.xml><?xml version="1.0" encoding="utf-8"?>
 <p:sld xmlns:a="http://schemas.openxmlformats.org/drawingml/2006/main" xmlns:r="http://schemas.openxmlformats.org/officeDocument/2006/relationships" xmlns:p="http://schemas.openxmlformats.org/presentationml/2006/main">
   <p:cSld>
@@ -33976,306 +33071,6 @@
         <p14:creationId xmlns:p14="http://schemas.microsoft.com/office/powerpoint/2010/main" val="2372039542"/>
       </p:ext>
     </p:extLst>
-  </p:cSld>
-  <p:clrMapOvr>
-    <a:masterClrMapping/>
-  </p:clrMapOvr>
-</p:sld>
-</file>
-
-<file path=ppt/slides/slide30.xml><?xml version="1.0" encoding="utf-8"?>
-<p:sld xmlns:a="http://schemas.openxmlformats.org/drawingml/2006/main" xmlns:r="http://schemas.openxmlformats.org/officeDocument/2006/relationships" xmlns:p="http://schemas.openxmlformats.org/presentationml/2006/main">
-  <p:cSld>
-    <p:spTree>
-      <p:nvGrpSpPr>
-        <p:cNvPr id="1" name=""/>
-        <p:cNvGrpSpPr/>
-        <p:nvPr/>
-      </p:nvGrpSpPr>
-      <p:grpSpPr>
-        <a:xfrm>
-          <a:off x="0" y="0"/>
-          <a:ext cx="0" cy="0"/>
-          <a:chOff x="0" y="0"/>
-          <a:chExt cx="0" cy="0"/>
-        </a:xfrm>
-      </p:grpSpPr>
-      <p:grpSp>
-        <p:nvGrpSpPr>
-          <p:cNvPr id="2" name="object 2"/>
-          <p:cNvGrpSpPr/>
-          <p:nvPr/>
-        </p:nvGrpSpPr>
-        <p:grpSpPr>
-          <a:xfrm>
-            <a:off x="0" y="2127504"/>
-            <a:ext cx="10058400" cy="4375785"/>
-            <a:chOff x="0" y="2127504"/>
-            <a:chExt cx="10058400" cy="4375785"/>
-          </a:xfrm>
-        </p:grpSpPr>
-        <p:sp>
-          <p:nvSpPr>
-            <p:cNvPr id="3" name="object 3"/>
-            <p:cNvSpPr/>
-            <p:nvPr/>
-          </p:nvSpPr>
-          <p:spPr>
-            <a:xfrm>
-              <a:off x="2598419" y="2127504"/>
-              <a:ext cx="2562225" cy="38100"/>
-            </a:xfrm>
-            <a:custGeom>
-              <a:avLst/>
-              <a:gdLst/>
-              <a:ahLst/>
-              <a:cxnLst/>
-              <a:rect l="l" t="t" r="r" b="b"/>
-              <a:pathLst>
-                <a:path w="2562225" h="38100">
-                  <a:moveTo>
-                    <a:pt x="2561844" y="38100"/>
-                  </a:moveTo>
-                  <a:lnTo>
-                    <a:pt x="0" y="38100"/>
-                  </a:lnTo>
-                  <a:lnTo>
-                    <a:pt x="0" y="0"/>
-                  </a:lnTo>
-                  <a:lnTo>
-                    <a:pt x="2561844" y="0"/>
-                  </a:lnTo>
-                  <a:lnTo>
-                    <a:pt x="2561844" y="38100"/>
-                  </a:lnTo>
-                  <a:close/>
-                </a:path>
-              </a:pathLst>
-            </a:custGeom>
-            <a:solidFill>
-              <a:srgbClr val="75C1E4"/>
-            </a:solidFill>
-          </p:spPr>
-          <p:txBody>
-            <a:bodyPr wrap="square" lIns="0" tIns="0" rIns="0" bIns="0" rtlCol="0"/>
-            <a:lstStyle/>
-            <a:p>
-              <a:endParaRPr/>
-            </a:p>
-          </p:txBody>
-        </p:sp>
-        <p:sp>
-          <p:nvSpPr>
-            <p:cNvPr id="4" name="object 4"/>
-            <p:cNvSpPr/>
-            <p:nvPr/>
-          </p:nvSpPr>
-          <p:spPr>
-            <a:xfrm>
-              <a:off x="0" y="2127504"/>
-              <a:ext cx="2598420" cy="38100"/>
-            </a:xfrm>
-            <a:custGeom>
-              <a:avLst/>
-              <a:gdLst/>
-              <a:ahLst/>
-              <a:cxnLst/>
-              <a:rect l="l" t="t" r="r" b="b"/>
-              <a:pathLst>
-                <a:path w="2598420" h="38100">
-                  <a:moveTo>
-                    <a:pt x="2598419" y="38100"/>
-                  </a:moveTo>
-                  <a:lnTo>
-                    <a:pt x="0" y="38100"/>
-                  </a:lnTo>
-                  <a:lnTo>
-                    <a:pt x="0" y="0"/>
-                  </a:lnTo>
-                  <a:lnTo>
-                    <a:pt x="2598419" y="0"/>
-                  </a:lnTo>
-                  <a:lnTo>
-                    <a:pt x="2598419" y="38100"/>
-                  </a:lnTo>
-                  <a:close/>
-                </a:path>
-              </a:pathLst>
-            </a:custGeom>
-            <a:solidFill>
-              <a:srgbClr val="FBAF16"/>
-            </a:solidFill>
-          </p:spPr>
-          <p:txBody>
-            <a:bodyPr wrap="square" lIns="0" tIns="0" rIns="0" bIns="0" rtlCol="0"/>
-            <a:lstStyle/>
-            <a:p>
-              <a:endParaRPr/>
-            </a:p>
-          </p:txBody>
-        </p:sp>
-        <p:sp>
-          <p:nvSpPr>
-            <p:cNvPr id="5" name="object 5"/>
-            <p:cNvSpPr/>
-            <p:nvPr/>
-          </p:nvSpPr>
-          <p:spPr>
-            <a:xfrm>
-              <a:off x="5151120" y="2127504"/>
-              <a:ext cx="2560320" cy="38100"/>
-            </a:xfrm>
-            <a:custGeom>
-              <a:avLst/>
-              <a:gdLst/>
-              <a:ahLst/>
-              <a:cxnLst/>
-              <a:rect l="l" t="t" r="r" b="b"/>
-              <a:pathLst>
-                <a:path w="2560320" h="38100">
-                  <a:moveTo>
-                    <a:pt x="2560319" y="38100"/>
-                  </a:moveTo>
-                  <a:lnTo>
-                    <a:pt x="0" y="38100"/>
-                  </a:lnTo>
-                  <a:lnTo>
-                    <a:pt x="0" y="0"/>
-                  </a:lnTo>
-                  <a:lnTo>
-                    <a:pt x="2560319" y="0"/>
-                  </a:lnTo>
-                  <a:lnTo>
-                    <a:pt x="2560319" y="38100"/>
-                  </a:lnTo>
-                  <a:close/>
-                </a:path>
-              </a:pathLst>
-            </a:custGeom>
-            <a:solidFill>
-              <a:srgbClr val="FF0000"/>
-            </a:solidFill>
-          </p:spPr>
-          <p:txBody>
-            <a:bodyPr wrap="square" lIns="0" tIns="0" rIns="0" bIns="0" rtlCol="0"/>
-            <a:lstStyle/>
-            <a:p>
-              <a:endParaRPr/>
-            </a:p>
-          </p:txBody>
-        </p:sp>
-        <p:pic>
-          <p:nvPicPr>
-            <p:cNvPr id="6" name="object 6"/>
-            <p:cNvPicPr/>
-            <p:nvPr/>
-          </p:nvPicPr>
-          <p:blipFill>
-            <a:blip r:embed="rId2" cstate="print"/>
-            <a:stretch>
-              <a:fillRect/>
-            </a:stretch>
-          </p:blipFill>
-          <p:spPr>
-            <a:xfrm>
-              <a:off x="0" y="2165604"/>
-              <a:ext cx="10058400" cy="4335779"/>
-            </a:xfrm>
-            <a:prstGeom prst="rect">
-              <a:avLst/>
-            </a:prstGeom>
-          </p:spPr>
-        </p:pic>
-      </p:grpSp>
-      <p:pic>
-        <p:nvPicPr>
-          <p:cNvPr id="7" name="object 7"/>
-          <p:cNvPicPr/>
-          <p:nvPr/>
-        </p:nvPicPr>
-        <p:blipFill>
-          <a:blip r:embed="rId3" cstate="print"/>
-          <a:stretch>
-            <a:fillRect/>
-          </a:stretch>
-        </p:blipFill>
-        <p:spPr>
-          <a:xfrm>
-            <a:off x="7292340" y="1057656"/>
-            <a:ext cx="2414016" cy="571499"/>
-          </a:xfrm>
-          <a:prstGeom prst="rect">
-            <a:avLst/>
-          </a:prstGeom>
-        </p:spPr>
-      </p:pic>
-      <p:sp>
-        <p:nvSpPr>
-          <p:cNvPr id="8" name="object 8"/>
-          <p:cNvSpPr txBox="1">
-            <a:spLocks noGrp="1"/>
-          </p:cNvSpPr>
-          <p:nvPr>
-            <p:ph type="ftr" sz="quarter" idx="5"/>
-          </p:nvPr>
-        </p:nvSpPr>
-        <p:spPr>
-          <a:prstGeom prst="rect">
-            <a:avLst/>
-          </a:prstGeom>
-        </p:spPr>
-        <p:txBody>
-          <a:bodyPr vert="horz" wrap="square" lIns="0" tIns="3175" rIns="0" bIns="0" rtlCol="0">
-            <a:spAutoFit/>
-          </a:bodyPr>
-          <a:lstStyle/>
-          <a:p>
-            <a:pPr marL="12700">
-              <a:lnSpc>
-                <a:spcPct val="100000"/>
-              </a:lnSpc>
-              <a:spcBef>
-                <a:spcPts val="25"/>
-              </a:spcBef>
-            </a:pPr>
-            <a:r>
-              <a:rPr b="1" dirty="0">
-                <a:latin typeface="Arial"/>
-                <a:cs typeface="Arial"/>
-              </a:rPr>
-              <a:t>BITS</a:t>
-            </a:r>
-            <a:r>
-              <a:rPr b="1" spc="-10" dirty="0">
-                <a:latin typeface="Arial"/>
-                <a:cs typeface="Arial"/>
-              </a:rPr>
-              <a:t> </a:t>
-            </a:r>
-            <a:r>
-              <a:rPr dirty="0"/>
-              <a:t>Pilani,</a:t>
-            </a:r>
-            <a:r>
-              <a:rPr spc="5" dirty="0"/>
-              <a:t> </a:t>
-            </a:r>
-            <a:r>
-              <a:rPr dirty="0"/>
-              <a:t>Pilani</a:t>
-            </a:r>
-            <a:r>
-              <a:rPr spc="10" dirty="0"/>
-              <a:t> </a:t>
-            </a:r>
-            <a:r>
-              <a:rPr spc="-10" dirty="0"/>
-              <a:t>Campus</a:t>
-            </a:r>
-          </a:p>
-        </p:txBody>
-      </p:sp>
-    </p:spTree>
   </p:cSld>
   <p:clrMapOvr>
     <a:masterClrMapping/>

</xml_diff>